<commit_message>
Sample table: both columns in the same unit, distinct adults
The all-months column now counts distinct adults seen across the
year's twelve monthly files (around 380,000, falling to 310,000) in
the same unit as the March supplement column, with the interview
totals moved to the footnote.

Co-Authored-By: Claude Fable 5 <noreply@anthropic.com>
Claude-Session: https://claude.ai/code/session_01DNzQPDcr3zfLTraMHUHqUn
</commit_message>
<xml_diff>
--- a/report/data_cluster/sample_sizes_slides.pptx
+++ b/report/data_cluster/sample_sizes_slides.pptx
@@ -4450,7 +4450,7 @@
                 </a:solidFill>
                 <a:latin typeface="Garamond"/>
               </a:rPr>
-              <a:t>1,230,200</a:t>
+              <a:t>385,573</a:t>
             </a:r>
           </a:p>
         </p:txBody>
@@ -4590,7 +4590,7 @@
                 </a:solidFill>
                 <a:latin typeface="Garamond"/>
               </a:rPr>
-              <a:t>1,221,832</a:t>
+              <a:t>382,007</a:t>
             </a:r>
           </a:p>
         </p:txBody>
@@ -4730,7 +4730,7 @@
                 </a:solidFill>
                 <a:latin typeface="Garamond"/>
               </a:rPr>
-              <a:t>1,211,261</a:t>
+              <a:t>377,803</a:t>
             </a:r>
           </a:p>
         </p:txBody>
@@ -4870,7 +4870,7 @@
                 </a:solidFill>
                 <a:latin typeface="Garamond"/>
               </a:rPr>
-              <a:t>1,209,862</a:t>
+              <a:t>376,110</a:t>
             </a:r>
           </a:p>
         </p:txBody>
@@ -5010,7 +5010,7 @@
                 </a:solidFill>
                 <a:latin typeface="Garamond"/>
               </a:rPr>
-              <a:t>1,226,441</a:t>
+              <a:t>379,674</a:t>
             </a:r>
           </a:p>
         </p:txBody>
@@ -5150,7 +5150,7 @@
                 </a:solidFill>
                 <a:latin typeface="Garamond"/>
               </a:rPr>
-              <a:t>1,230,780</a:t>
+              <a:t>381,708</a:t>
             </a:r>
           </a:p>
         </p:txBody>
@@ -5290,7 +5290,7 @@
                 </a:solidFill>
                 <a:latin typeface="Garamond"/>
               </a:rPr>
-              <a:t>1,221,274</a:t>
+              <a:t>379,927</a:t>
             </a:r>
           </a:p>
         </p:txBody>
@@ -5678,7 +5678,7 @@
                 </a:solidFill>
                 <a:latin typeface="Garamond"/>
               </a:rPr>
-              <a:t>1,215,614</a:t>
+              <a:t>378,498</a:t>
             </a:r>
           </a:p>
         </p:txBody>
@@ -5818,7 +5818,7 @@
                 </a:solidFill>
                 <a:latin typeface="Garamond"/>
               </a:rPr>
-              <a:t>1,210,672</a:t>
+              <a:t>378,505</a:t>
             </a:r>
           </a:p>
         </p:txBody>
@@ -5958,7 +5958,7 @@
                 </a:solidFill>
                 <a:latin typeface="Garamond"/>
               </a:rPr>
-              <a:t>1,218,742</a:t>
+              <a:t>387,617</a:t>
             </a:r>
           </a:p>
         </p:txBody>
@@ -6098,7 +6098,7 @@
                 </a:solidFill>
                 <a:latin typeface="Garamond"/>
               </a:rPr>
-              <a:t>1,203,862</a:t>
+              <a:t>381,968</a:t>
             </a:r>
           </a:p>
         </p:txBody>
@@ -6238,7 +6238,7 @@
                 </a:solidFill>
                 <a:latin typeface="Garamond"/>
               </a:rPr>
-              <a:t>1,202,067</a:t>
+              <a:t>381,159</a:t>
             </a:r>
           </a:p>
         </p:txBody>
@@ -6378,7 +6378,7 @@
                 </a:solidFill>
                 <a:latin typeface="Garamond"/>
               </a:rPr>
-              <a:t>1,186,031</a:t>
+              <a:t>376,197</a:t>
             </a:r>
           </a:p>
         </p:txBody>
@@ -6518,7 +6518,7 @@
                 </a:solidFill>
                 <a:latin typeface="Garamond"/>
               </a:rPr>
-              <a:t>1,150,355</a:t>
+              <a:t>366,072</a:t>
             </a:r>
           </a:p>
         </p:txBody>
@@ -6658,7 +6658,7 @@
                 </a:solidFill>
                 <a:latin typeface="Garamond"/>
               </a:rPr>
-              <a:t>1,112,619</a:t>
+              <a:t>356,027</a:t>
             </a:r>
           </a:p>
         </p:txBody>
@@ -6798,7 +6798,7 @@
                 </a:solidFill>
                 <a:latin typeface="Garamond"/>
               </a:rPr>
-              <a:t>1,001,837</a:t>
+              <a:t>335,867</a:t>
             </a:r>
           </a:p>
         </p:txBody>
@@ -6938,7 +6938,7 @@
                 </a:solidFill>
                 <a:latin typeface="Garamond"/>
               </a:rPr>
-              <a:t>1,006,676</a:t>
+              <a:t>331,439</a:t>
             </a:r>
           </a:p>
         </p:txBody>
@@ -7078,7 +7078,7 @@
                 </a:solidFill>
                 <a:latin typeface="Garamond"/>
               </a:rPr>
-              <a:t>964,927</a:t>
+              <a:t>317,729</a:t>
             </a:r>
           </a:p>
         </p:txBody>
@@ -7218,7 +7218,7 @@
                 </a:solidFill>
                 <a:latin typeface="Garamond"/>
               </a:rPr>
-              <a:t>948,329</a:t>
+              <a:t>312,873</a:t>
             </a:r>
           </a:p>
         </p:txBody>
@@ -7358,7 +7358,7 @@
                 </a:solidFill>
                 <a:latin typeface="Garamond"/>
               </a:rPr>
-              <a:t>944,897</a:t>
+              <a:t>310,239</a:t>
             </a:r>
           </a:p>
         </p:txBody>
@@ -7498,7 +7498,7 @@
                 </a:solidFill>
                 <a:latin typeface="Garamond"/>
               </a:rPr>
-              <a:t>833,766*</a:t>
+              <a:t>302,652*</a:t>
             </a:r>
           </a:p>
         </p:txBody>
@@ -7569,7 +7569,7 @@
                 </a:solidFill>
                 <a:latin typeface="Garamond"/>
               </a:rPr>
-              <a:t>Total   3,607,763 adults, 103,820 teachers (ASEC);  22,918,278 monthly interviews (2005–24)</a:t>
+              <a:t>Total (ASEC)   3,607,763 adults, 103,820 teachers</a:t>
             </a:r>
           </a:p>
         </p:txBody>
@@ -7604,7 +7604,7 @@
                 </a:solidFill>
                 <a:latin typeface="Garamond"/>
               </a:rPr>
-              <a:t>Adults (18+), the analysis universe; with children the ASEC files hold 5.0 million records. All 12 months: adult interviews in that year's basic monthly files (cached from 2005; * 2025: eleven months).</a:t>
+              <a:t>Distinct adults (18+) in both columns. The supplement interviews each person once; the basic survey interviews each adult about three times a year (0.9–1.2 million interviews), so we keep about one person in three and one interview in eight (monthly files cached from 2005; * 2025: eleven months).</a:t>
             </a:r>
           </a:p>
         </p:txBody>

</xml_diff>

<commit_message>
Single-line column headers on the monthly sample table
Columns read New, Seen this yr, Seen last yr, Total, with the footnote
and row labels using the same names.

Co-Authored-By: Claude Fable 5 <noreply@anthropic.com>
Claude-Session: https://claude.ai/code/session_01DNzQPDcr3zfLTraMHUHqUn
</commit_message>
<xml_diff>
--- a/report/data_cluster/sample_sizes_slides.pptx
+++ b/report/data_cluster/sample_sizes_slides.pptx
@@ -7897,7 +7897,7 @@
         <p:spPr>
           <a:xfrm>
             <a:off x="457200" y="1106424"/>
-            <a:ext cx="10680191" cy="0"/>
+            <a:ext cx="10844784" cy="0"/>
           </a:xfrm>
           <a:prstGeom prst="line">
             <a:avLst/>
@@ -7933,7 +7933,7 @@
         <p:spPr>
           <a:xfrm>
             <a:off x="1371600" y="1152144"/>
-            <a:ext cx="3108960" cy="219456"/>
+            <a:ext cx="3163824" cy="219456"/>
           </a:xfrm>
           <a:prstGeom prst="rect">
             <a:avLst/>
@@ -7968,7 +7968,7 @@
         <p:spPr>
           <a:xfrm>
             <a:off x="1371600" y="1399032"/>
-            <a:ext cx="694944" cy="164592"/>
+            <a:ext cx="603504" cy="164592"/>
           </a:xfrm>
           <a:prstGeom prst="rect">
             <a:avLst/>
@@ -8002,8 +8002,8 @@
         </p:nvSpPr>
         <p:spPr>
           <a:xfrm>
-            <a:off x="2066543" y="1399032"/>
-            <a:ext cx="841248" cy="164592"/>
+            <a:off x="1975104" y="1399032"/>
+            <a:ext cx="914400" cy="164592"/>
           </a:xfrm>
           <a:prstGeom prst="rect">
             <a:avLst/>
@@ -8024,8 +8024,7 @@
                 </a:solidFill>
                 <a:latin typeface="Garamond"/>
               </a:rPr>
-              <a:t>Earlier
-this year</a:t>
+              <a:t>Seen this yr</a:t>
             </a:r>
           </a:p>
         </p:txBody>
@@ -8038,8 +8037,8 @@
         </p:nvSpPr>
         <p:spPr>
           <a:xfrm>
-            <a:off x="2907791" y="1399032"/>
-            <a:ext cx="786384" cy="164592"/>
+            <a:off x="2889504" y="1399032"/>
+            <a:ext cx="914400" cy="164592"/>
           </a:xfrm>
           <a:prstGeom prst="rect">
             <a:avLst/>
@@ -8060,8 +8059,7 @@
                 </a:solidFill>
                 <a:latin typeface="Garamond"/>
               </a:rPr>
-              <a:t>Last
-year</a:t>
+              <a:t>Seen last yr</a:t>
             </a:r>
           </a:p>
         </p:txBody>
@@ -8074,8 +8072,8 @@
         </p:nvSpPr>
         <p:spPr>
           <a:xfrm>
-            <a:off x="3694176" y="1399032"/>
-            <a:ext cx="786384" cy="164592"/>
+            <a:off x="3803904" y="1399032"/>
+            <a:ext cx="731520" cy="164592"/>
           </a:xfrm>
           <a:prstGeom prst="rect">
             <a:avLst/>
@@ -8109,8 +8107,8 @@
         </p:nvSpPr>
         <p:spPr>
           <a:xfrm>
-            <a:off x="4700016" y="1152144"/>
-            <a:ext cx="3108960" cy="219456"/>
+            <a:off x="4754880" y="1152144"/>
+            <a:ext cx="3163824" cy="219456"/>
           </a:xfrm>
           <a:prstGeom prst="rect">
             <a:avLst/>
@@ -8144,8 +8142,8 @@
         </p:nvSpPr>
         <p:spPr>
           <a:xfrm>
-            <a:off x="4700016" y="1399032"/>
-            <a:ext cx="694944" cy="164592"/>
+            <a:off x="4754880" y="1399032"/>
+            <a:ext cx="603504" cy="164592"/>
           </a:xfrm>
           <a:prstGeom prst="rect">
             <a:avLst/>
@@ -8179,8 +8177,8 @@
         </p:nvSpPr>
         <p:spPr>
           <a:xfrm>
-            <a:off x="5394959" y="1399032"/>
-            <a:ext cx="841248" cy="164592"/>
+            <a:off x="5358384" y="1399032"/>
+            <a:ext cx="914400" cy="164592"/>
           </a:xfrm>
           <a:prstGeom prst="rect">
             <a:avLst/>
@@ -8201,8 +8199,7 @@
                 </a:solidFill>
                 <a:latin typeface="Garamond"/>
               </a:rPr>
-              <a:t>Earlier
-this year</a:t>
+              <a:t>Seen this yr</a:t>
             </a:r>
           </a:p>
         </p:txBody>
@@ -8215,8 +8212,8 @@
         </p:nvSpPr>
         <p:spPr>
           <a:xfrm>
-            <a:off x="6236207" y="1399032"/>
-            <a:ext cx="786384" cy="164592"/>
+            <a:off x="6272784" y="1399032"/>
+            <a:ext cx="914400" cy="164592"/>
           </a:xfrm>
           <a:prstGeom prst="rect">
             <a:avLst/>
@@ -8237,8 +8234,7 @@
                 </a:solidFill>
                 <a:latin typeface="Garamond"/>
               </a:rPr>
-              <a:t>Last
-year</a:t>
+              <a:t>Seen last yr</a:t>
             </a:r>
           </a:p>
         </p:txBody>
@@ -8251,8 +8247,8 @@
         </p:nvSpPr>
         <p:spPr>
           <a:xfrm>
-            <a:off x="7022592" y="1399032"/>
-            <a:ext cx="786384" cy="164592"/>
+            <a:off x="7187184" y="1399032"/>
+            <a:ext cx="731520" cy="164592"/>
           </a:xfrm>
           <a:prstGeom prst="rect">
             <a:avLst/>
@@ -8286,8 +8282,8 @@
         </p:nvSpPr>
         <p:spPr>
           <a:xfrm>
-            <a:off x="8028431" y="1152144"/>
-            <a:ext cx="3108960" cy="219456"/>
+            <a:off x="8138160" y="1152144"/>
+            <a:ext cx="3163824" cy="219456"/>
           </a:xfrm>
           <a:prstGeom prst="rect">
             <a:avLst/>
@@ -8321,8 +8317,8 @@
         </p:nvSpPr>
         <p:spPr>
           <a:xfrm>
-            <a:off x="8028431" y="1399032"/>
-            <a:ext cx="694944" cy="164592"/>
+            <a:off x="8138160" y="1399032"/>
+            <a:ext cx="603504" cy="164592"/>
           </a:xfrm>
           <a:prstGeom prst="rect">
             <a:avLst/>
@@ -8356,8 +8352,8 @@
         </p:nvSpPr>
         <p:spPr>
           <a:xfrm>
-            <a:off x="8723376" y="1399032"/>
-            <a:ext cx="841248" cy="164592"/>
+            <a:off x="8741664" y="1399032"/>
+            <a:ext cx="914400" cy="164592"/>
           </a:xfrm>
           <a:prstGeom prst="rect">
             <a:avLst/>
@@ -8378,8 +8374,7 @@
                 </a:solidFill>
                 <a:latin typeface="Garamond"/>
               </a:rPr>
-              <a:t>Earlier
-this year</a:t>
+              <a:t>Seen this yr</a:t>
             </a:r>
           </a:p>
         </p:txBody>
@@ -8392,8 +8387,8 @@
         </p:nvSpPr>
         <p:spPr>
           <a:xfrm>
-            <a:off x="9564624" y="1399032"/>
-            <a:ext cx="786384" cy="164592"/>
+            <a:off x="9656064" y="1399032"/>
+            <a:ext cx="914400" cy="164592"/>
           </a:xfrm>
           <a:prstGeom prst="rect">
             <a:avLst/>
@@ -8414,8 +8409,7 @@
                 </a:solidFill>
                 <a:latin typeface="Garamond"/>
               </a:rPr>
-              <a:t>Last
-year</a:t>
+              <a:t>Seen last yr</a:t>
             </a:r>
           </a:p>
         </p:txBody>
@@ -8428,8 +8422,8 @@
         </p:nvSpPr>
         <p:spPr>
           <a:xfrm>
-            <a:off x="10351007" y="1399032"/>
-            <a:ext cx="786384" cy="164592"/>
+            <a:off x="10570464" y="1399032"/>
+            <a:ext cx="731520" cy="164592"/>
           </a:xfrm>
           <a:prstGeom prst="rect">
             <a:avLst/>
@@ -8463,8 +8457,8 @@
         </p:nvCxnSpPr>
         <p:spPr>
           <a:xfrm>
-            <a:off x="457200" y="1828800"/>
-            <a:ext cx="10680191" cy="0"/>
+            <a:off x="457200" y="1664208"/>
+            <a:ext cx="10844784" cy="0"/>
           </a:xfrm>
           <a:prstGeom prst="line">
             <a:avLst/>
@@ -8499,7 +8493,7 @@
         </p:nvSpPr>
         <p:spPr>
           <a:xfrm>
-            <a:off x="457200" y="1901952"/>
+            <a:off x="457200" y="1737360"/>
             <a:ext cx="914400" cy="173736"/>
           </a:xfrm>
           <a:prstGeom prst="rect">
@@ -8534,8 +8528,8 @@
         </p:nvSpPr>
         <p:spPr>
           <a:xfrm>
-            <a:off x="1371600" y="1901952"/>
-            <a:ext cx="694944" cy="173736"/>
+            <a:off x="1371600" y="1737360"/>
+            <a:ext cx="603504" cy="173736"/>
           </a:xfrm>
           <a:prstGeom prst="rect">
             <a:avLst/>
@@ -8569,8 +8563,8 @@
         </p:nvSpPr>
         <p:spPr>
           <a:xfrm>
-            <a:off x="2066543" y="1901952"/>
-            <a:ext cx="841248" cy="173736"/>
+            <a:off x="1975104" y="1737360"/>
+            <a:ext cx="914400" cy="173736"/>
           </a:xfrm>
           <a:prstGeom prst="rect">
             <a:avLst/>
@@ -8604,8 +8598,8 @@
         </p:nvSpPr>
         <p:spPr>
           <a:xfrm>
-            <a:off x="2907791" y="1901952"/>
-            <a:ext cx="786384" cy="173736"/>
+            <a:off x="2889504" y="1737360"/>
+            <a:ext cx="914400" cy="173736"/>
           </a:xfrm>
           <a:prstGeom prst="rect">
             <a:avLst/>
@@ -8639,8 +8633,8 @@
         </p:nvSpPr>
         <p:spPr>
           <a:xfrm>
-            <a:off x="3694176" y="1901952"/>
-            <a:ext cx="786384" cy="173736"/>
+            <a:off x="3803904" y="1737360"/>
+            <a:ext cx="731520" cy="173736"/>
           </a:xfrm>
           <a:prstGeom prst="rect">
             <a:avLst/>
@@ -8674,8 +8668,8 @@
         </p:nvSpPr>
         <p:spPr>
           <a:xfrm>
-            <a:off x="4700016" y="1901952"/>
-            <a:ext cx="694944" cy="173736"/>
+            <a:off x="4754880" y="1737360"/>
+            <a:ext cx="603504" cy="173736"/>
           </a:xfrm>
           <a:prstGeom prst="rect">
             <a:avLst/>
@@ -8709,8 +8703,8 @@
         </p:nvSpPr>
         <p:spPr>
           <a:xfrm>
-            <a:off x="5394959" y="1901952"/>
-            <a:ext cx="841248" cy="173736"/>
+            <a:off x="5358384" y="1737360"/>
+            <a:ext cx="914400" cy="173736"/>
           </a:xfrm>
           <a:prstGeom prst="rect">
             <a:avLst/>
@@ -8744,8 +8738,8 @@
         </p:nvSpPr>
         <p:spPr>
           <a:xfrm>
-            <a:off x="6236207" y="1901952"/>
-            <a:ext cx="786384" cy="173736"/>
+            <a:off x="6272784" y="1737360"/>
+            <a:ext cx="914400" cy="173736"/>
           </a:xfrm>
           <a:prstGeom prst="rect">
             <a:avLst/>
@@ -8779,8 +8773,8 @@
         </p:nvSpPr>
         <p:spPr>
           <a:xfrm>
-            <a:off x="7022592" y="1901952"/>
-            <a:ext cx="786384" cy="173736"/>
+            <a:off x="7187184" y="1737360"/>
+            <a:ext cx="731520" cy="173736"/>
           </a:xfrm>
           <a:prstGeom prst="rect">
             <a:avLst/>
@@ -8814,8 +8808,8 @@
         </p:nvSpPr>
         <p:spPr>
           <a:xfrm>
-            <a:off x="8028431" y="1901952"/>
-            <a:ext cx="694944" cy="173736"/>
+            <a:off x="8138160" y="1737360"/>
+            <a:ext cx="603504" cy="173736"/>
           </a:xfrm>
           <a:prstGeom prst="rect">
             <a:avLst/>
@@ -8849,8 +8843,8 @@
         </p:nvSpPr>
         <p:spPr>
           <a:xfrm>
-            <a:off x="8723376" y="1901952"/>
-            <a:ext cx="841248" cy="173736"/>
+            <a:off x="8741664" y="1737360"/>
+            <a:ext cx="914400" cy="173736"/>
           </a:xfrm>
           <a:prstGeom prst="rect">
             <a:avLst/>
@@ -8884,8 +8878,8 @@
         </p:nvSpPr>
         <p:spPr>
           <a:xfrm>
-            <a:off x="9564624" y="1901952"/>
-            <a:ext cx="786384" cy="173736"/>
+            <a:off x="9656064" y="1737360"/>
+            <a:ext cx="914400" cy="173736"/>
           </a:xfrm>
           <a:prstGeom prst="rect">
             <a:avLst/>
@@ -8919,8 +8913,8 @@
         </p:nvSpPr>
         <p:spPr>
           <a:xfrm>
-            <a:off x="10351007" y="1901952"/>
-            <a:ext cx="786384" cy="173736"/>
+            <a:off x="10570464" y="1737360"/>
+            <a:ext cx="731520" cy="173736"/>
           </a:xfrm>
           <a:prstGeom prst="rect">
             <a:avLst/>
@@ -8954,7 +8948,7 @@
         </p:nvSpPr>
         <p:spPr>
           <a:xfrm>
-            <a:off x="457200" y="2114092"/>
+            <a:off x="457200" y="1949500"/>
             <a:ext cx="914400" cy="173736"/>
           </a:xfrm>
           <a:prstGeom prst="rect">
@@ -8989,8 +8983,8 @@
         </p:nvSpPr>
         <p:spPr>
           <a:xfrm>
-            <a:off x="1371600" y="2114092"/>
-            <a:ext cx="694944" cy="173736"/>
+            <a:off x="1371600" y="1949500"/>
+            <a:ext cx="603504" cy="173736"/>
           </a:xfrm>
           <a:prstGeom prst="rect">
             <a:avLst/>
@@ -9024,8 +9018,8 @@
         </p:nvSpPr>
         <p:spPr>
           <a:xfrm>
-            <a:off x="2066543" y="2114092"/>
-            <a:ext cx="841248" cy="173736"/>
+            <a:off x="1975104" y="1949500"/>
+            <a:ext cx="914400" cy="173736"/>
           </a:xfrm>
           <a:prstGeom prst="rect">
             <a:avLst/>
@@ -9059,8 +9053,8 @@
         </p:nvSpPr>
         <p:spPr>
           <a:xfrm>
-            <a:off x="2907791" y="2114092"/>
-            <a:ext cx="786384" cy="173736"/>
+            <a:off x="2889504" y="1949500"/>
+            <a:ext cx="914400" cy="173736"/>
           </a:xfrm>
           <a:prstGeom prst="rect">
             <a:avLst/>
@@ -9094,8 +9088,8 @@
         </p:nvSpPr>
         <p:spPr>
           <a:xfrm>
-            <a:off x="3694176" y="2114092"/>
-            <a:ext cx="786384" cy="173736"/>
+            <a:off x="3803904" y="1949500"/>
+            <a:ext cx="731520" cy="173736"/>
           </a:xfrm>
           <a:prstGeom prst="rect">
             <a:avLst/>
@@ -9129,8 +9123,8 @@
         </p:nvSpPr>
         <p:spPr>
           <a:xfrm>
-            <a:off x="4700016" y="2114092"/>
-            <a:ext cx="694944" cy="173736"/>
+            <a:off x="4754880" y="1949500"/>
+            <a:ext cx="603504" cy="173736"/>
           </a:xfrm>
           <a:prstGeom prst="rect">
             <a:avLst/>
@@ -9164,8 +9158,8 @@
         </p:nvSpPr>
         <p:spPr>
           <a:xfrm>
-            <a:off x="5394959" y="2114092"/>
-            <a:ext cx="841248" cy="173736"/>
+            <a:off x="5358384" y="1949500"/>
+            <a:ext cx="914400" cy="173736"/>
           </a:xfrm>
           <a:prstGeom prst="rect">
             <a:avLst/>
@@ -9199,8 +9193,8 @@
         </p:nvSpPr>
         <p:spPr>
           <a:xfrm>
-            <a:off x="6236207" y="2114092"/>
-            <a:ext cx="786384" cy="173736"/>
+            <a:off x="6272784" y="1949500"/>
+            <a:ext cx="914400" cy="173736"/>
           </a:xfrm>
           <a:prstGeom prst="rect">
             <a:avLst/>
@@ -9234,8 +9228,8 @@
         </p:nvSpPr>
         <p:spPr>
           <a:xfrm>
-            <a:off x="7022592" y="2114092"/>
-            <a:ext cx="786384" cy="173736"/>
+            <a:off x="7187184" y="1949500"/>
+            <a:ext cx="731520" cy="173736"/>
           </a:xfrm>
           <a:prstGeom prst="rect">
             <a:avLst/>
@@ -9269,8 +9263,8 @@
         </p:nvSpPr>
         <p:spPr>
           <a:xfrm>
-            <a:off x="8028431" y="2114092"/>
-            <a:ext cx="694944" cy="173736"/>
+            <a:off x="8138160" y="1949500"/>
+            <a:ext cx="603504" cy="173736"/>
           </a:xfrm>
           <a:prstGeom prst="rect">
             <a:avLst/>
@@ -9304,8 +9298,8 @@
         </p:nvSpPr>
         <p:spPr>
           <a:xfrm>
-            <a:off x="8723376" y="2114092"/>
-            <a:ext cx="841248" cy="173736"/>
+            <a:off x="8741664" y="1949500"/>
+            <a:ext cx="914400" cy="173736"/>
           </a:xfrm>
           <a:prstGeom prst="rect">
             <a:avLst/>
@@ -9339,8 +9333,8 @@
         </p:nvSpPr>
         <p:spPr>
           <a:xfrm>
-            <a:off x="9564624" y="2114092"/>
-            <a:ext cx="786384" cy="173736"/>
+            <a:off x="9656064" y="1949500"/>
+            <a:ext cx="914400" cy="173736"/>
           </a:xfrm>
           <a:prstGeom prst="rect">
             <a:avLst/>
@@ -9374,8 +9368,8 @@
         </p:nvSpPr>
         <p:spPr>
           <a:xfrm>
-            <a:off x="10351007" y="2114092"/>
-            <a:ext cx="786384" cy="173736"/>
+            <a:off x="10570464" y="1949500"/>
+            <a:ext cx="731520" cy="173736"/>
           </a:xfrm>
           <a:prstGeom prst="rect">
             <a:avLst/>
@@ -9409,7 +9403,7 @@
         </p:nvSpPr>
         <p:spPr>
           <a:xfrm>
-            <a:off x="457200" y="2326233"/>
+            <a:off x="457200" y="2161641"/>
             <a:ext cx="914400" cy="173736"/>
           </a:xfrm>
           <a:prstGeom prst="rect">
@@ -9444,8 +9438,8 @@
         </p:nvSpPr>
         <p:spPr>
           <a:xfrm>
-            <a:off x="1371600" y="2326233"/>
-            <a:ext cx="694944" cy="173736"/>
+            <a:off x="1371600" y="2161641"/>
+            <a:ext cx="603504" cy="173736"/>
           </a:xfrm>
           <a:prstGeom prst="rect">
             <a:avLst/>
@@ -9479,8 +9473,8 @@
         </p:nvSpPr>
         <p:spPr>
           <a:xfrm>
-            <a:off x="2066543" y="2326233"/>
-            <a:ext cx="841248" cy="173736"/>
+            <a:off x="1975104" y="2161641"/>
+            <a:ext cx="914400" cy="173736"/>
           </a:xfrm>
           <a:prstGeom prst="rect">
             <a:avLst/>
@@ -9514,8 +9508,8 @@
         </p:nvSpPr>
         <p:spPr>
           <a:xfrm>
-            <a:off x="2907791" y="2326233"/>
-            <a:ext cx="786384" cy="173736"/>
+            <a:off x="2889504" y="2161641"/>
+            <a:ext cx="914400" cy="173736"/>
           </a:xfrm>
           <a:prstGeom prst="rect">
             <a:avLst/>
@@ -9549,8 +9543,8 @@
         </p:nvSpPr>
         <p:spPr>
           <a:xfrm>
-            <a:off x="3694176" y="2326233"/>
-            <a:ext cx="786384" cy="173736"/>
+            <a:off x="3803904" y="2161641"/>
+            <a:ext cx="731520" cy="173736"/>
           </a:xfrm>
           <a:prstGeom prst="rect">
             <a:avLst/>
@@ -9584,8 +9578,8 @@
         </p:nvSpPr>
         <p:spPr>
           <a:xfrm>
-            <a:off x="4700016" y="2326233"/>
-            <a:ext cx="694944" cy="173736"/>
+            <a:off x="4754880" y="2161641"/>
+            <a:ext cx="603504" cy="173736"/>
           </a:xfrm>
           <a:prstGeom prst="rect">
             <a:avLst/>
@@ -9619,8 +9613,8 @@
         </p:nvSpPr>
         <p:spPr>
           <a:xfrm>
-            <a:off x="5394959" y="2326233"/>
-            <a:ext cx="841248" cy="173736"/>
+            <a:off x="5358384" y="2161641"/>
+            <a:ext cx="914400" cy="173736"/>
           </a:xfrm>
           <a:prstGeom prst="rect">
             <a:avLst/>
@@ -9654,8 +9648,8 @@
         </p:nvSpPr>
         <p:spPr>
           <a:xfrm>
-            <a:off x="6236207" y="2326233"/>
-            <a:ext cx="786384" cy="173736"/>
+            <a:off x="6272784" y="2161641"/>
+            <a:ext cx="914400" cy="173736"/>
           </a:xfrm>
           <a:prstGeom prst="rect">
             <a:avLst/>
@@ -9689,8 +9683,8 @@
         </p:nvSpPr>
         <p:spPr>
           <a:xfrm>
-            <a:off x="7022592" y="2326233"/>
-            <a:ext cx="786384" cy="173736"/>
+            <a:off x="7187184" y="2161641"/>
+            <a:ext cx="731520" cy="173736"/>
           </a:xfrm>
           <a:prstGeom prst="rect">
             <a:avLst/>
@@ -9724,8 +9718,8 @@
         </p:nvSpPr>
         <p:spPr>
           <a:xfrm>
-            <a:off x="8028431" y="2326233"/>
-            <a:ext cx="694944" cy="173736"/>
+            <a:off x="8138160" y="2161641"/>
+            <a:ext cx="603504" cy="173736"/>
           </a:xfrm>
           <a:prstGeom prst="rect">
             <a:avLst/>
@@ -9759,8 +9753,8 @@
         </p:nvSpPr>
         <p:spPr>
           <a:xfrm>
-            <a:off x="8723376" y="2326233"/>
-            <a:ext cx="841248" cy="173736"/>
+            <a:off x="8741664" y="2161641"/>
+            <a:ext cx="914400" cy="173736"/>
           </a:xfrm>
           <a:prstGeom prst="rect">
             <a:avLst/>
@@ -9794,8 +9788,8 @@
         </p:nvSpPr>
         <p:spPr>
           <a:xfrm>
-            <a:off x="9564624" y="2326233"/>
-            <a:ext cx="786384" cy="173736"/>
+            <a:off x="9656064" y="2161641"/>
+            <a:ext cx="914400" cy="173736"/>
           </a:xfrm>
           <a:prstGeom prst="rect">
             <a:avLst/>
@@ -9829,8 +9823,8 @@
         </p:nvSpPr>
         <p:spPr>
           <a:xfrm>
-            <a:off x="10351007" y="2326233"/>
-            <a:ext cx="786384" cy="173736"/>
+            <a:off x="10570464" y="2161641"/>
+            <a:ext cx="731520" cy="173736"/>
           </a:xfrm>
           <a:prstGeom prst="rect">
             <a:avLst/>
@@ -9864,7 +9858,7 @@
         </p:nvSpPr>
         <p:spPr>
           <a:xfrm>
-            <a:off x="457200" y="2538374"/>
+            <a:off x="457200" y="2373782"/>
             <a:ext cx="914400" cy="173736"/>
           </a:xfrm>
           <a:prstGeom prst="rect">
@@ -9899,8 +9893,8 @@
         </p:nvSpPr>
         <p:spPr>
           <a:xfrm>
-            <a:off x="1371600" y="2538374"/>
-            <a:ext cx="694944" cy="173736"/>
+            <a:off x="1371600" y="2373782"/>
+            <a:ext cx="603504" cy="173736"/>
           </a:xfrm>
           <a:prstGeom prst="rect">
             <a:avLst/>
@@ -9934,8 +9928,8 @@
         </p:nvSpPr>
         <p:spPr>
           <a:xfrm>
-            <a:off x="2066543" y="2538374"/>
-            <a:ext cx="841248" cy="173736"/>
+            <a:off x="1975104" y="2373782"/>
+            <a:ext cx="914400" cy="173736"/>
           </a:xfrm>
           <a:prstGeom prst="rect">
             <a:avLst/>
@@ -9969,8 +9963,8 @@
         </p:nvSpPr>
         <p:spPr>
           <a:xfrm>
-            <a:off x="2907791" y="2538374"/>
-            <a:ext cx="786384" cy="173736"/>
+            <a:off x="2889504" y="2373782"/>
+            <a:ext cx="914400" cy="173736"/>
           </a:xfrm>
           <a:prstGeom prst="rect">
             <a:avLst/>
@@ -10004,8 +9998,8 @@
         </p:nvSpPr>
         <p:spPr>
           <a:xfrm>
-            <a:off x="3694176" y="2538374"/>
-            <a:ext cx="786384" cy="173736"/>
+            <a:off x="3803904" y="2373782"/>
+            <a:ext cx="731520" cy="173736"/>
           </a:xfrm>
           <a:prstGeom prst="rect">
             <a:avLst/>
@@ -10039,8 +10033,8 @@
         </p:nvSpPr>
         <p:spPr>
           <a:xfrm>
-            <a:off x="4700016" y="2538374"/>
-            <a:ext cx="694944" cy="173736"/>
+            <a:off x="4754880" y="2373782"/>
+            <a:ext cx="603504" cy="173736"/>
           </a:xfrm>
           <a:prstGeom prst="rect">
             <a:avLst/>
@@ -10074,8 +10068,8 @@
         </p:nvSpPr>
         <p:spPr>
           <a:xfrm>
-            <a:off x="5394959" y="2538374"/>
-            <a:ext cx="841248" cy="173736"/>
+            <a:off x="5358384" y="2373782"/>
+            <a:ext cx="914400" cy="173736"/>
           </a:xfrm>
           <a:prstGeom prst="rect">
             <a:avLst/>
@@ -10109,8 +10103,8 @@
         </p:nvSpPr>
         <p:spPr>
           <a:xfrm>
-            <a:off x="6236207" y="2538374"/>
-            <a:ext cx="786384" cy="173736"/>
+            <a:off x="6272784" y="2373782"/>
+            <a:ext cx="914400" cy="173736"/>
           </a:xfrm>
           <a:prstGeom prst="rect">
             <a:avLst/>
@@ -10144,8 +10138,8 @@
         </p:nvSpPr>
         <p:spPr>
           <a:xfrm>
-            <a:off x="7022592" y="2538374"/>
-            <a:ext cx="786384" cy="173736"/>
+            <a:off x="7187184" y="2373782"/>
+            <a:ext cx="731520" cy="173736"/>
           </a:xfrm>
           <a:prstGeom prst="rect">
             <a:avLst/>
@@ -10179,8 +10173,8 @@
         </p:nvSpPr>
         <p:spPr>
           <a:xfrm>
-            <a:off x="8028431" y="2538374"/>
-            <a:ext cx="694944" cy="173736"/>
+            <a:off x="8138160" y="2373782"/>
+            <a:ext cx="603504" cy="173736"/>
           </a:xfrm>
           <a:prstGeom prst="rect">
             <a:avLst/>
@@ -10214,8 +10208,8 @@
         </p:nvSpPr>
         <p:spPr>
           <a:xfrm>
-            <a:off x="8723376" y="2538374"/>
-            <a:ext cx="841248" cy="173736"/>
+            <a:off x="8741664" y="2373782"/>
+            <a:ext cx="914400" cy="173736"/>
           </a:xfrm>
           <a:prstGeom prst="rect">
             <a:avLst/>
@@ -10249,8 +10243,8 @@
         </p:nvSpPr>
         <p:spPr>
           <a:xfrm>
-            <a:off x="9564624" y="2538374"/>
-            <a:ext cx="786384" cy="173736"/>
+            <a:off x="9656064" y="2373782"/>
+            <a:ext cx="914400" cy="173736"/>
           </a:xfrm>
           <a:prstGeom prst="rect">
             <a:avLst/>
@@ -10284,8 +10278,8 @@
         </p:nvSpPr>
         <p:spPr>
           <a:xfrm>
-            <a:off x="10351007" y="2538374"/>
-            <a:ext cx="786384" cy="173736"/>
+            <a:off x="10570464" y="2373782"/>
+            <a:ext cx="731520" cy="173736"/>
           </a:xfrm>
           <a:prstGeom prst="rect">
             <a:avLst/>
@@ -10319,7 +10313,7 @@
         </p:nvSpPr>
         <p:spPr>
           <a:xfrm>
-            <a:off x="457200" y="2750515"/>
+            <a:off x="457200" y="2585923"/>
             <a:ext cx="914400" cy="173736"/>
           </a:xfrm>
           <a:prstGeom prst="rect">
@@ -10354,8 +10348,8 @@
         </p:nvSpPr>
         <p:spPr>
           <a:xfrm>
-            <a:off x="1371600" y="2750515"/>
-            <a:ext cx="694944" cy="173736"/>
+            <a:off x="1371600" y="2585923"/>
+            <a:ext cx="603504" cy="173736"/>
           </a:xfrm>
           <a:prstGeom prst="rect">
             <a:avLst/>
@@ -10389,8 +10383,8 @@
         </p:nvSpPr>
         <p:spPr>
           <a:xfrm>
-            <a:off x="2066543" y="2750515"/>
-            <a:ext cx="841248" cy="173736"/>
+            <a:off x="1975104" y="2585923"/>
+            <a:ext cx="914400" cy="173736"/>
           </a:xfrm>
           <a:prstGeom prst="rect">
             <a:avLst/>
@@ -10424,8 +10418,8 @@
         </p:nvSpPr>
         <p:spPr>
           <a:xfrm>
-            <a:off x="2907791" y="2750515"/>
-            <a:ext cx="786384" cy="173736"/>
+            <a:off x="2889504" y="2585923"/>
+            <a:ext cx="914400" cy="173736"/>
           </a:xfrm>
           <a:prstGeom prst="rect">
             <a:avLst/>
@@ -10459,8 +10453,8 @@
         </p:nvSpPr>
         <p:spPr>
           <a:xfrm>
-            <a:off x="3694176" y="2750515"/>
-            <a:ext cx="786384" cy="173736"/>
+            <a:off x="3803904" y="2585923"/>
+            <a:ext cx="731520" cy="173736"/>
           </a:xfrm>
           <a:prstGeom prst="rect">
             <a:avLst/>
@@ -10494,8 +10488,8 @@
         </p:nvSpPr>
         <p:spPr>
           <a:xfrm>
-            <a:off x="4700016" y="2750515"/>
-            <a:ext cx="694944" cy="173736"/>
+            <a:off x="4754880" y="2585923"/>
+            <a:ext cx="603504" cy="173736"/>
           </a:xfrm>
           <a:prstGeom prst="rect">
             <a:avLst/>
@@ -10529,8 +10523,8 @@
         </p:nvSpPr>
         <p:spPr>
           <a:xfrm>
-            <a:off x="5394959" y="2750515"/>
-            <a:ext cx="841248" cy="173736"/>
+            <a:off x="5358384" y="2585923"/>
+            <a:ext cx="914400" cy="173736"/>
           </a:xfrm>
           <a:prstGeom prst="rect">
             <a:avLst/>
@@ -10564,8 +10558,8 @@
         </p:nvSpPr>
         <p:spPr>
           <a:xfrm>
-            <a:off x="6236207" y="2750515"/>
-            <a:ext cx="786384" cy="173736"/>
+            <a:off x="6272784" y="2585923"/>
+            <a:ext cx="914400" cy="173736"/>
           </a:xfrm>
           <a:prstGeom prst="rect">
             <a:avLst/>
@@ -10599,8 +10593,8 @@
         </p:nvSpPr>
         <p:spPr>
           <a:xfrm>
-            <a:off x="7022592" y="2750515"/>
-            <a:ext cx="786384" cy="173736"/>
+            <a:off x="7187184" y="2585923"/>
+            <a:ext cx="731520" cy="173736"/>
           </a:xfrm>
           <a:prstGeom prst="rect">
             <a:avLst/>
@@ -10634,8 +10628,8 @@
         </p:nvSpPr>
         <p:spPr>
           <a:xfrm>
-            <a:off x="8028431" y="2750515"/>
-            <a:ext cx="694944" cy="173736"/>
+            <a:off x="8138160" y="2585923"/>
+            <a:ext cx="603504" cy="173736"/>
           </a:xfrm>
           <a:prstGeom prst="rect">
             <a:avLst/>
@@ -10669,8 +10663,8 @@
         </p:nvSpPr>
         <p:spPr>
           <a:xfrm>
-            <a:off x="8723376" y="2750515"/>
-            <a:ext cx="841248" cy="173736"/>
+            <a:off x="8741664" y="2585923"/>
+            <a:ext cx="914400" cy="173736"/>
           </a:xfrm>
           <a:prstGeom prst="rect">
             <a:avLst/>
@@ -10704,8 +10698,8 @@
         </p:nvSpPr>
         <p:spPr>
           <a:xfrm>
-            <a:off x="9564624" y="2750515"/>
-            <a:ext cx="786384" cy="173736"/>
+            <a:off x="9656064" y="2585923"/>
+            <a:ext cx="914400" cy="173736"/>
           </a:xfrm>
           <a:prstGeom prst="rect">
             <a:avLst/>
@@ -10739,8 +10733,8 @@
         </p:nvSpPr>
         <p:spPr>
           <a:xfrm>
-            <a:off x="10351007" y="2750515"/>
-            <a:ext cx="786384" cy="173736"/>
+            <a:off x="10570464" y="2585923"/>
+            <a:ext cx="731520" cy="173736"/>
           </a:xfrm>
           <a:prstGeom prst="rect">
             <a:avLst/>
@@ -10774,7 +10768,7 @@
         </p:nvSpPr>
         <p:spPr>
           <a:xfrm>
-            <a:off x="457200" y="2962656"/>
+            <a:off x="457200" y="2798064"/>
             <a:ext cx="914400" cy="173736"/>
           </a:xfrm>
           <a:prstGeom prst="rect">
@@ -10809,8 +10803,8 @@
         </p:nvSpPr>
         <p:spPr>
           <a:xfrm>
-            <a:off x="1371600" y="2962656"/>
-            <a:ext cx="694944" cy="173736"/>
+            <a:off x="1371600" y="2798064"/>
+            <a:ext cx="603504" cy="173736"/>
           </a:xfrm>
           <a:prstGeom prst="rect">
             <a:avLst/>
@@ -10844,8 +10838,8 @@
         </p:nvSpPr>
         <p:spPr>
           <a:xfrm>
-            <a:off x="2066543" y="2962656"/>
-            <a:ext cx="841248" cy="173736"/>
+            <a:off x="1975104" y="2798064"/>
+            <a:ext cx="914400" cy="173736"/>
           </a:xfrm>
           <a:prstGeom prst="rect">
             <a:avLst/>
@@ -10879,8 +10873,8 @@
         </p:nvSpPr>
         <p:spPr>
           <a:xfrm>
-            <a:off x="2907791" y="2962656"/>
-            <a:ext cx="786384" cy="173736"/>
+            <a:off x="2889504" y="2798064"/>
+            <a:ext cx="914400" cy="173736"/>
           </a:xfrm>
           <a:prstGeom prst="rect">
             <a:avLst/>
@@ -10914,8 +10908,8 @@
         </p:nvSpPr>
         <p:spPr>
           <a:xfrm>
-            <a:off x="3694176" y="2962656"/>
-            <a:ext cx="786384" cy="173736"/>
+            <a:off x="3803904" y="2798064"/>
+            <a:ext cx="731520" cy="173736"/>
           </a:xfrm>
           <a:prstGeom prst="rect">
             <a:avLst/>
@@ -10949,8 +10943,8 @@
         </p:nvSpPr>
         <p:spPr>
           <a:xfrm>
-            <a:off x="4700016" y="2962656"/>
-            <a:ext cx="694944" cy="173736"/>
+            <a:off x="4754880" y="2798064"/>
+            <a:ext cx="603504" cy="173736"/>
           </a:xfrm>
           <a:prstGeom prst="rect">
             <a:avLst/>
@@ -10984,8 +10978,8 @@
         </p:nvSpPr>
         <p:spPr>
           <a:xfrm>
-            <a:off x="5394959" y="2962656"/>
-            <a:ext cx="841248" cy="173736"/>
+            <a:off x="5358384" y="2798064"/>
+            <a:ext cx="914400" cy="173736"/>
           </a:xfrm>
           <a:prstGeom prst="rect">
             <a:avLst/>
@@ -11019,8 +11013,8 @@
         </p:nvSpPr>
         <p:spPr>
           <a:xfrm>
-            <a:off x="6236207" y="2962656"/>
-            <a:ext cx="786384" cy="173736"/>
+            <a:off x="6272784" y="2798064"/>
+            <a:ext cx="914400" cy="173736"/>
           </a:xfrm>
           <a:prstGeom prst="rect">
             <a:avLst/>
@@ -11054,8 +11048,8 @@
         </p:nvSpPr>
         <p:spPr>
           <a:xfrm>
-            <a:off x="7022592" y="2962656"/>
-            <a:ext cx="786384" cy="173736"/>
+            <a:off x="7187184" y="2798064"/>
+            <a:ext cx="731520" cy="173736"/>
           </a:xfrm>
           <a:prstGeom prst="rect">
             <a:avLst/>
@@ -11089,8 +11083,8 @@
         </p:nvSpPr>
         <p:spPr>
           <a:xfrm>
-            <a:off x="8028431" y="2962656"/>
-            <a:ext cx="694944" cy="173736"/>
+            <a:off x="8138160" y="2798064"/>
+            <a:ext cx="603504" cy="173736"/>
           </a:xfrm>
           <a:prstGeom prst="rect">
             <a:avLst/>
@@ -11124,8 +11118,8 @@
         </p:nvSpPr>
         <p:spPr>
           <a:xfrm>
-            <a:off x="8723376" y="2962656"/>
-            <a:ext cx="841248" cy="173736"/>
+            <a:off x="8741664" y="2798064"/>
+            <a:ext cx="914400" cy="173736"/>
           </a:xfrm>
           <a:prstGeom prst="rect">
             <a:avLst/>
@@ -11159,8 +11153,8 @@
         </p:nvSpPr>
         <p:spPr>
           <a:xfrm>
-            <a:off x="9564624" y="2962656"/>
-            <a:ext cx="786384" cy="173736"/>
+            <a:off x="9656064" y="2798064"/>
+            <a:ext cx="914400" cy="173736"/>
           </a:xfrm>
           <a:prstGeom prst="rect">
             <a:avLst/>
@@ -11194,8 +11188,8 @@
         </p:nvSpPr>
         <p:spPr>
           <a:xfrm>
-            <a:off x="10351007" y="2962656"/>
-            <a:ext cx="786384" cy="173736"/>
+            <a:off x="10570464" y="2798064"/>
+            <a:ext cx="731520" cy="173736"/>
           </a:xfrm>
           <a:prstGeom prst="rect">
             <a:avLst/>
@@ -11229,7 +11223,7 @@
         </p:nvSpPr>
         <p:spPr>
           <a:xfrm>
-            <a:off x="457200" y="3174796"/>
+            <a:off x="457200" y="3010204"/>
             <a:ext cx="914400" cy="173736"/>
           </a:xfrm>
           <a:prstGeom prst="rect">
@@ -11264,8 +11258,8 @@
         </p:nvSpPr>
         <p:spPr>
           <a:xfrm>
-            <a:off x="1371600" y="3174796"/>
-            <a:ext cx="694944" cy="173736"/>
+            <a:off x="1371600" y="3010204"/>
+            <a:ext cx="603504" cy="173736"/>
           </a:xfrm>
           <a:prstGeom prst="rect">
             <a:avLst/>
@@ -11299,8 +11293,8 @@
         </p:nvSpPr>
         <p:spPr>
           <a:xfrm>
-            <a:off x="2066543" y="3174796"/>
-            <a:ext cx="841248" cy="173736"/>
+            <a:off x="1975104" y="3010204"/>
+            <a:ext cx="914400" cy="173736"/>
           </a:xfrm>
           <a:prstGeom prst="rect">
             <a:avLst/>
@@ -11334,8 +11328,8 @@
         </p:nvSpPr>
         <p:spPr>
           <a:xfrm>
-            <a:off x="2907791" y="3174796"/>
-            <a:ext cx="786384" cy="173736"/>
+            <a:off x="2889504" y="3010204"/>
+            <a:ext cx="914400" cy="173736"/>
           </a:xfrm>
           <a:prstGeom prst="rect">
             <a:avLst/>
@@ -11369,8 +11363,8 @@
         </p:nvSpPr>
         <p:spPr>
           <a:xfrm>
-            <a:off x="3694176" y="3174796"/>
-            <a:ext cx="786384" cy="173736"/>
+            <a:off x="3803904" y="3010204"/>
+            <a:ext cx="731520" cy="173736"/>
           </a:xfrm>
           <a:prstGeom prst="rect">
             <a:avLst/>
@@ -11404,8 +11398,8 @@
         </p:nvSpPr>
         <p:spPr>
           <a:xfrm>
-            <a:off x="4700016" y="3174796"/>
-            <a:ext cx="694944" cy="173736"/>
+            <a:off x="4754880" y="3010204"/>
+            <a:ext cx="603504" cy="173736"/>
           </a:xfrm>
           <a:prstGeom prst="rect">
             <a:avLst/>
@@ -11439,8 +11433,8 @@
         </p:nvSpPr>
         <p:spPr>
           <a:xfrm>
-            <a:off x="5394959" y="3174796"/>
-            <a:ext cx="841248" cy="173736"/>
+            <a:off x="5358384" y="3010204"/>
+            <a:ext cx="914400" cy="173736"/>
           </a:xfrm>
           <a:prstGeom prst="rect">
             <a:avLst/>
@@ -11474,8 +11468,8 @@
         </p:nvSpPr>
         <p:spPr>
           <a:xfrm>
-            <a:off x="6236207" y="3174796"/>
-            <a:ext cx="786384" cy="173736"/>
+            <a:off x="6272784" y="3010204"/>
+            <a:ext cx="914400" cy="173736"/>
           </a:xfrm>
           <a:prstGeom prst="rect">
             <a:avLst/>
@@ -11509,8 +11503,8 @@
         </p:nvSpPr>
         <p:spPr>
           <a:xfrm>
-            <a:off x="7022592" y="3174796"/>
-            <a:ext cx="786384" cy="173736"/>
+            <a:off x="7187184" y="3010204"/>
+            <a:ext cx="731520" cy="173736"/>
           </a:xfrm>
           <a:prstGeom prst="rect">
             <a:avLst/>
@@ -11544,8 +11538,8 @@
         </p:nvSpPr>
         <p:spPr>
           <a:xfrm>
-            <a:off x="8028431" y="3174796"/>
-            <a:ext cx="694944" cy="173736"/>
+            <a:off x="8138160" y="3010204"/>
+            <a:ext cx="603504" cy="173736"/>
           </a:xfrm>
           <a:prstGeom prst="rect">
             <a:avLst/>
@@ -11579,8 +11573,8 @@
         </p:nvSpPr>
         <p:spPr>
           <a:xfrm>
-            <a:off x="8723376" y="3174796"/>
-            <a:ext cx="841248" cy="173736"/>
+            <a:off x="8741664" y="3010204"/>
+            <a:ext cx="914400" cy="173736"/>
           </a:xfrm>
           <a:prstGeom prst="rect">
             <a:avLst/>
@@ -11614,8 +11608,8 @@
         </p:nvSpPr>
         <p:spPr>
           <a:xfrm>
-            <a:off x="9564624" y="3174796"/>
-            <a:ext cx="786384" cy="173736"/>
+            <a:off x="9656064" y="3010204"/>
+            <a:ext cx="914400" cy="173736"/>
           </a:xfrm>
           <a:prstGeom prst="rect">
             <a:avLst/>
@@ -11649,8 +11643,8 @@
         </p:nvSpPr>
         <p:spPr>
           <a:xfrm>
-            <a:off x="10351007" y="3174796"/>
-            <a:ext cx="786384" cy="173736"/>
+            <a:off x="10570464" y="3010204"/>
+            <a:ext cx="731520" cy="173736"/>
           </a:xfrm>
           <a:prstGeom prst="rect">
             <a:avLst/>
@@ -11684,7 +11678,7 @@
         </p:nvSpPr>
         <p:spPr>
           <a:xfrm>
-            <a:off x="457200" y="3386937"/>
+            <a:off x="457200" y="3222345"/>
             <a:ext cx="914400" cy="173736"/>
           </a:xfrm>
           <a:prstGeom prst="rect">
@@ -11719,8 +11713,8 @@
         </p:nvSpPr>
         <p:spPr>
           <a:xfrm>
-            <a:off x="1371600" y="3386937"/>
-            <a:ext cx="694944" cy="173736"/>
+            <a:off x="1371600" y="3222345"/>
+            <a:ext cx="603504" cy="173736"/>
           </a:xfrm>
           <a:prstGeom prst="rect">
             <a:avLst/>
@@ -11754,8 +11748,8 @@
         </p:nvSpPr>
         <p:spPr>
           <a:xfrm>
-            <a:off x="2066543" y="3386937"/>
-            <a:ext cx="841248" cy="173736"/>
+            <a:off x="1975104" y="3222345"/>
+            <a:ext cx="914400" cy="173736"/>
           </a:xfrm>
           <a:prstGeom prst="rect">
             <a:avLst/>
@@ -11789,8 +11783,8 @@
         </p:nvSpPr>
         <p:spPr>
           <a:xfrm>
-            <a:off x="2907791" y="3386937"/>
-            <a:ext cx="786384" cy="173736"/>
+            <a:off x="2889504" y="3222345"/>
+            <a:ext cx="914400" cy="173736"/>
           </a:xfrm>
           <a:prstGeom prst="rect">
             <a:avLst/>
@@ -11824,8 +11818,8 @@
         </p:nvSpPr>
         <p:spPr>
           <a:xfrm>
-            <a:off x="3694176" y="3386937"/>
-            <a:ext cx="786384" cy="173736"/>
+            <a:off x="3803904" y="3222345"/>
+            <a:ext cx="731520" cy="173736"/>
           </a:xfrm>
           <a:prstGeom prst="rect">
             <a:avLst/>
@@ -11859,8 +11853,8 @@
         </p:nvSpPr>
         <p:spPr>
           <a:xfrm>
-            <a:off x="4700016" y="3386937"/>
-            <a:ext cx="694944" cy="173736"/>
+            <a:off x="4754880" y="3222345"/>
+            <a:ext cx="603504" cy="173736"/>
           </a:xfrm>
           <a:prstGeom prst="rect">
             <a:avLst/>
@@ -11894,8 +11888,8 @@
         </p:nvSpPr>
         <p:spPr>
           <a:xfrm>
-            <a:off x="5394959" y="3386937"/>
-            <a:ext cx="841248" cy="173736"/>
+            <a:off x="5358384" y="3222345"/>
+            <a:ext cx="914400" cy="173736"/>
           </a:xfrm>
           <a:prstGeom prst="rect">
             <a:avLst/>
@@ -11929,8 +11923,8 @@
         </p:nvSpPr>
         <p:spPr>
           <a:xfrm>
-            <a:off x="6236207" y="3386937"/>
-            <a:ext cx="786384" cy="173736"/>
+            <a:off x="6272784" y="3222345"/>
+            <a:ext cx="914400" cy="173736"/>
           </a:xfrm>
           <a:prstGeom prst="rect">
             <a:avLst/>
@@ -11964,8 +11958,8 @@
         </p:nvSpPr>
         <p:spPr>
           <a:xfrm>
-            <a:off x="7022592" y="3386937"/>
-            <a:ext cx="786384" cy="173736"/>
+            <a:off x="7187184" y="3222345"/>
+            <a:ext cx="731520" cy="173736"/>
           </a:xfrm>
           <a:prstGeom prst="rect">
             <a:avLst/>
@@ -11999,8 +11993,8 @@
         </p:nvSpPr>
         <p:spPr>
           <a:xfrm>
-            <a:off x="8028431" y="3386937"/>
-            <a:ext cx="694944" cy="173736"/>
+            <a:off x="8138160" y="3222345"/>
+            <a:ext cx="603504" cy="173736"/>
           </a:xfrm>
           <a:prstGeom prst="rect">
             <a:avLst/>
@@ -12034,8 +12028,8 @@
         </p:nvSpPr>
         <p:spPr>
           <a:xfrm>
-            <a:off x="8723376" y="3386937"/>
-            <a:ext cx="841248" cy="173736"/>
+            <a:off x="8741664" y="3222345"/>
+            <a:ext cx="914400" cy="173736"/>
           </a:xfrm>
           <a:prstGeom prst="rect">
             <a:avLst/>
@@ -12069,8 +12063,8 @@
         </p:nvSpPr>
         <p:spPr>
           <a:xfrm>
-            <a:off x="9564624" y="3386937"/>
-            <a:ext cx="786384" cy="173736"/>
+            <a:off x="9656064" y="3222345"/>
+            <a:ext cx="914400" cy="173736"/>
           </a:xfrm>
           <a:prstGeom prst="rect">
             <a:avLst/>
@@ -12104,8 +12098,8 @@
         </p:nvSpPr>
         <p:spPr>
           <a:xfrm>
-            <a:off x="10351007" y="3386937"/>
-            <a:ext cx="786384" cy="173736"/>
+            <a:off x="10570464" y="3222345"/>
+            <a:ext cx="731520" cy="173736"/>
           </a:xfrm>
           <a:prstGeom prst="rect">
             <a:avLst/>
@@ -12139,7 +12133,7 @@
         </p:nvSpPr>
         <p:spPr>
           <a:xfrm>
-            <a:off x="457200" y="3599078"/>
+            <a:off x="457200" y="3434486"/>
             <a:ext cx="914400" cy="173736"/>
           </a:xfrm>
           <a:prstGeom prst="rect">
@@ -12174,8 +12168,8 @@
         </p:nvSpPr>
         <p:spPr>
           <a:xfrm>
-            <a:off x="1371600" y="3599078"/>
-            <a:ext cx="694944" cy="173736"/>
+            <a:off x="1371600" y="3434486"/>
+            <a:ext cx="603504" cy="173736"/>
           </a:xfrm>
           <a:prstGeom prst="rect">
             <a:avLst/>
@@ -12209,8 +12203,8 @@
         </p:nvSpPr>
         <p:spPr>
           <a:xfrm>
-            <a:off x="2066543" y="3599078"/>
-            <a:ext cx="841248" cy="173736"/>
+            <a:off x="1975104" y="3434486"/>
+            <a:ext cx="914400" cy="173736"/>
           </a:xfrm>
           <a:prstGeom prst="rect">
             <a:avLst/>
@@ -12244,8 +12238,8 @@
         </p:nvSpPr>
         <p:spPr>
           <a:xfrm>
-            <a:off x="2907791" y="3599078"/>
-            <a:ext cx="786384" cy="173736"/>
+            <a:off x="2889504" y="3434486"/>
+            <a:ext cx="914400" cy="173736"/>
           </a:xfrm>
           <a:prstGeom prst="rect">
             <a:avLst/>
@@ -12279,8 +12273,8 @@
         </p:nvSpPr>
         <p:spPr>
           <a:xfrm>
-            <a:off x="3694176" y="3599078"/>
-            <a:ext cx="786384" cy="173736"/>
+            <a:off x="3803904" y="3434486"/>
+            <a:ext cx="731520" cy="173736"/>
           </a:xfrm>
           <a:prstGeom prst="rect">
             <a:avLst/>
@@ -12314,8 +12308,8 @@
         </p:nvSpPr>
         <p:spPr>
           <a:xfrm>
-            <a:off x="4700016" y="3599078"/>
-            <a:ext cx="694944" cy="173736"/>
+            <a:off x="4754880" y="3434486"/>
+            <a:ext cx="603504" cy="173736"/>
           </a:xfrm>
           <a:prstGeom prst="rect">
             <a:avLst/>
@@ -12349,8 +12343,8 @@
         </p:nvSpPr>
         <p:spPr>
           <a:xfrm>
-            <a:off x="5394959" y="3599078"/>
-            <a:ext cx="841248" cy="173736"/>
+            <a:off x="5358384" y="3434486"/>
+            <a:ext cx="914400" cy="173736"/>
           </a:xfrm>
           <a:prstGeom prst="rect">
             <a:avLst/>
@@ -12384,8 +12378,8 @@
         </p:nvSpPr>
         <p:spPr>
           <a:xfrm>
-            <a:off x="6236207" y="3599078"/>
-            <a:ext cx="786384" cy="173736"/>
+            <a:off x="6272784" y="3434486"/>
+            <a:ext cx="914400" cy="173736"/>
           </a:xfrm>
           <a:prstGeom prst="rect">
             <a:avLst/>
@@ -12419,8 +12413,8 @@
         </p:nvSpPr>
         <p:spPr>
           <a:xfrm>
-            <a:off x="7022592" y="3599078"/>
-            <a:ext cx="786384" cy="173736"/>
+            <a:off x="7187184" y="3434486"/>
+            <a:ext cx="731520" cy="173736"/>
           </a:xfrm>
           <a:prstGeom prst="rect">
             <a:avLst/>
@@ -12454,8 +12448,8 @@
         </p:nvSpPr>
         <p:spPr>
           <a:xfrm>
-            <a:off x="8028431" y="3599078"/>
-            <a:ext cx="694944" cy="173736"/>
+            <a:off x="8138160" y="3434486"/>
+            <a:ext cx="603504" cy="173736"/>
           </a:xfrm>
           <a:prstGeom prst="rect">
             <a:avLst/>
@@ -12489,8 +12483,8 @@
         </p:nvSpPr>
         <p:spPr>
           <a:xfrm>
-            <a:off x="8723376" y="3599078"/>
-            <a:ext cx="841248" cy="173736"/>
+            <a:off x="8741664" y="3434486"/>
+            <a:ext cx="914400" cy="173736"/>
           </a:xfrm>
           <a:prstGeom prst="rect">
             <a:avLst/>
@@ -12524,8 +12518,8 @@
         </p:nvSpPr>
         <p:spPr>
           <a:xfrm>
-            <a:off x="9564624" y="3599078"/>
-            <a:ext cx="786384" cy="173736"/>
+            <a:off x="9656064" y="3434486"/>
+            <a:ext cx="914400" cy="173736"/>
           </a:xfrm>
           <a:prstGeom prst="rect">
             <a:avLst/>
@@ -12559,8 +12553,8 @@
         </p:nvSpPr>
         <p:spPr>
           <a:xfrm>
-            <a:off x="10351007" y="3599078"/>
-            <a:ext cx="786384" cy="173736"/>
+            <a:off x="10570464" y="3434486"/>
+            <a:ext cx="731520" cy="173736"/>
           </a:xfrm>
           <a:prstGeom prst="rect">
             <a:avLst/>
@@ -12594,7 +12588,7 @@
         </p:nvSpPr>
         <p:spPr>
           <a:xfrm>
-            <a:off x="457200" y="3811219"/>
+            <a:off x="457200" y="3646627"/>
             <a:ext cx="914400" cy="173736"/>
           </a:xfrm>
           <a:prstGeom prst="rect">
@@ -12629,8 +12623,8 @@
         </p:nvSpPr>
         <p:spPr>
           <a:xfrm>
-            <a:off x="1371600" y="3811219"/>
-            <a:ext cx="694944" cy="173736"/>
+            <a:off x="1371600" y="3646627"/>
+            <a:ext cx="603504" cy="173736"/>
           </a:xfrm>
           <a:prstGeom prst="rect">
             <a:avLst/>
@@ -12664,8 +12658,8 @@
         </p:nvSpPr>
         <p:spPr>
           <a:xfrm>
-            <a:off x="2066543" y="3811219"/>
-            <a:ext cx="841248" cy="173736"/>
+            <a:off x="1975104" y="3646627"/>
+            <a:ext cx="914400" cy="173736"/>
           </a:xfrm>
           <a:prstGeom prst="rect">
             <a:avLst/>
@@ -12699,8 +12693,8 @@
         </p:nvSpPr>
         <p:spPr>
           <a:xfrm>
-            <a:off x="2907791" y="3811219"/>
-            <a:ext cx="786384" cy="173736"/>
+            <a:off x="2889504" y="3646627"/>
+            <a:ext cx="914400" cy="173736"/>
           </a:xfrm>
           <a:prstGeom prst="rect">
             <a:avLst/>
@@ -12734,8 +12728,8 @@
         </p:nvSpPr>
         <p:spPr>
           <a:xfrm>
-            <a:off x="3694176" y="3811219"/>
-            <a:ext cx="786384" cy="173736"/>
+            <a:off x="3803904" y="3646627"/>
+            <a:ext cx="731520" cy="173736"/>
           </a:xfrm>
           <a:prstGeom prst="rect">
             <a:avLst/>
@@ -12769,8 +12763,8 @@
         </p:nvSpPr>
         <p:spPr>
           <a:xfrm>
-            <a:off x="4700016" y="3811219"/>
-            <a:ext cx="694944" cy="173736"/>
+            <a:off x="4754880" y="3646627"/>
+            <a:ext cx="603504" cy="173736"/>
           </a:xfrm>
           <a:prstGeom prst="rect">
             <a:avLst/>
@@ -12804,8 +12798,8 @@
         </p:nvSpPr>
         <p:spPr>
           <a:xfrm>
-            <a:off x="5394959" y="3811219"/>
-            <a:ext cx="841248" cy="173736"/>
+            <a:off x="5358384" y="3646627"/>
+            <a:ext cx="914400" cy="173736"/>
           </a:xfrm>
           <a:prstGeom prst="rect">
             <a:avLst/>
@@ -12839,8 +12833,8 @@
         </p:nvSpPr>
         <p:spPr>
           <a:xfrm>
-            <a:off x="6236207" y="3811219"/>
-            <a:ext cx="786384" cy="173736"/>
+            <a:off x="6272784" y="3646627"/>
+            <a:ext cx="914400" cy="173736"/>
           </a:xfrm>
           <a:prstGeom prst="rect">
             <a:avLst/>
@@ -12874,8 +12868,8 @@
         </p:nvSpPr>
         <p:spPr>
           <a:xfrm>
-            <a:off x="7022592" y="3811219"/>
-            <a:ext cx="786384" cy="173736"/>
+            <a:off x="7187184" y="3646627"/>
+            <a:ext cx="731520" cy="173736"/>
           </a:xfrm>
           <a:prstGeom prst="rect">
             <a:avLst/>
@@ -12909,8 +12903,8 @@
         </p:nvSpPr>
         <p:spPr>
           <a:xfrm>
-            <a:off x="8028431" y="3811219"/>
-            <a:ext cx="694944" cy="173736"/>
+            <a:off x="8138160" y="3646627"/>
+            <a:ext cx="603504" cy="173736"/>
           </a:xfrm>
           <a:prstGeom prst="rect">
             <a:avLst/>
@@ -12944,8 +12938,8 @@
         </p:nvSpPr>
         <p:spPr>
           <a:xfrm>
-            <a:off x="8723376" y="3811219"/>
-            <a:ext cx="841248" cy="173736"/>
+            <a:off x="8741664" y="3646627"/>
+            <a:ext cx="914400" cy="173736"/>
           </a:xfrm>
           <a:prstGeom prst="rect">
             <a:avLst/>
@@ -12979,8 +12973,8 @@
         </p:nvSpPr>
         <p:spPr>
           <a:xfrm>
-            <a:off x="9564624" y="3811219"/>
-            <a:ext cx="786384" cy="173736"/>
+            <a:off x="9656064" y="3646627"/>
+            <a:ext cx="914400" cy="173736"/>
           </a:xfrm>
           <a:prstGeom prst="rect">
             <a:avLst/>
@@ -13014,8 +13008,8 @@
         </p:nvSpPr>
         <p:spPr>
           <a:xfrm>
-            <a:off x="10351007" y="3811219"/>
-            <a:ext cx="786384" cy="173736"/>
+            <a:off x="10570464" y="3646627"/>
+            <a:ext cx="731520" cy="173736"/>
           </a:xfrm>
           <a:prstGeom prst="rect">
             <a:avLst/>
@@ -13049,7 +13043,7 @@
         </p:nvSpPr>
         <p:spPr>
           <a:xfrm>
-            <a:off x="457200" y="4023360"/>
+            <a:off x="457200" y="3858768"/>
             <a:ext cx="914400" cy="173736"/>
           </a:xfrm>
           <a:prstGeom prst="rect">
@@ -13084,8 +13078,8 @@
         </p:nvSpPr>
         <p:spPr>
           <a:xfrm>
-            <a:off x="1371600" y="4023360"/>
-            <a:ext cx="694944" cy="173736"/>
+            <a:off x="1371600" y="3858768"/>
+            <a:ext cx="603504" cy="173736"/>
           </a:xfrm>
           <a:prstGeom prst="rect">
             <a:avLst/>
@@ -13119,8 +13113,8 @@
         </p:nvSpPr>
         <p:spPr>
           <a:xfrm>
-            <a:off x="2066543" y="4023360"/>
-            <a:ext cx="841248" cy="173736"/>
+            <a:off x="1975104" y="3858768"/>
+            <a:ext cx="914400" cy="173736"/>
           </a:xfrm>
           <a:prstGeom prst="rect">
             <a:avLst/>
@@ -13154,8 +13148,8 @@
         </p:nvSpPr>
         <p:spPr>
           <a:xfrm>
-            <a:off x="2907791" y="4023360"/>
-            <a:ext cx="786384" cy="173736"/>
+            <a:off x="2889504" y="3858768"/>
+            <a:ext cx="914400" cy="173736"/>
           </a:xfrm>
           <a:prstGeom prst="rect">
             <a:avLst/>
@@ -13189,8 +13183,8 @@
         </p:nvSpPr>
         <p:spPr>
           <a:xfrm>
-            <a:off x="3694176" y="4023360"/>
-            <a:ext cx="786384" cy="173736"/>
+            <a:off x="3803904" y="3858768"/>
+            <a:ext cx="731520" cy="173736"/>
           </a:xfrm>
           <a:prstGeom prst="rect">
             <a:avLst/>
@@ -13224,8 +13218,8 @@
         </p:nvSpPr>
         <p:spPr>
           <a:xfrm>
-            <a:off x="4700016" y="4023360"/>
-            <a:ext cx="694944" cy="173736"/>
+            <a:off x="4754880" y="3858768"/>
+            <a:ext cx="603504" cy="173736"/>
           </a:xfrm>
           <a:prstGeom prst="rect">
             <a:avLst/>
@@ -13259,8 +13253,8 @@
         </p:nvSpPr>
         <p:spPr>
           <a:xfrm>
-            <a:off x="5394959" y="4023360"/>
-            <a:ext cx="841248" cy="173736"/>
+            <a:off x="5358384" y="3858768"/>
+            <a:ext cx="914400" cy="173736"/>
           </a:xfrm>
           <a:prstGeom prst="rect">
             <a:avLst/>
@@ -13294,8 +13288,8 @@
         </p:nvSpPr>
         <p:spPr>
           <a:xfrm>
-            <a:off x="6236207" y="4023360"/>
-            <a:ext cx="786384" cy="173736"/>
+            <a:off x="6272784" y="3858768"/>
+            <a:ext cx="914400" cy="173736"/>
           </a:xfrm>
           <a:prstGeom prst="rect">
             <a:avLst/>
@@ -13329,8 +13323,8 @@
         </p:nvSpPr>
         <p:spPr>
           <a:xfrm>
-            <a:off x="7022592" y="4023360"/>
-            <a:ext cx="786384" cy="173736"/>
+            <a:off x="7187184" y="3858768"/>
+            <a:ext cx="731520" cy="173736"/>
           </a:xfrm>
           <a:prstGeom prst="rect">
             <a:avLst/>
@@ -13364,8 +13358,8 @@
         </p:nvSpPr>
         <p:spPr>
           <a:xfrm>
-            <a:off x="8028431" y="4023360"/>
-            <a:ext cx="694944" cy="173736"/>
+            <a:off x="8138160" y="3858768"/>
+            <a:ext cx="603504" cy="173736"/>
           </a:xfrm>
           <a:prstGeom prst="rect">
             <a:avLst/>
@@ -13399,8 +13393,8 @@
         </p:nvSpPr>
         <p:spPr>
           <a:xfrm>
-            <a:off x="8723376" y="4023360"/>
-            <a:ext cx="841248" cy="173736"/>
+            <a:off x="8741664" y="3858768"/>
+            <a:ext cx="914400" cy="173736"/>
           </a:xfrm>
           <a:prstGeom prst="rect">
             <a:avLst/>
@@ -13434,8 +13428,8 @@
         </p:nvSpPr>
         <p:spPr>
           <a:xfrm>
-            <a:off x="9564624" y="4023360"/>
-            <a:ext cx="786384" cy="173736"/>
+            <a:off x="9656064" y="3858768"/>
+            <a:ext cx="914400" cy="173736"/>
           </a:xfrm>
           <a:prstGeom prst="rect">
             <a:avLst/>
@@ -13469,8 +13463,8 @@
         </p:nvSpPr>
         <p:spPr>
           <a:xfrm>
-            <a:off x="10351007" y="4023360"/>
-            <a:ext cx="786384" cy="173736"/>
+            <a:off x="10570464" y="3858768"/>
+            <a:ext cx="731520" cy="173736"/>
           </a:xfrm>
           <a:prstGeom prst="rect">
             <a:avLst/>
@@ -13504,7 +13498,7 @@
         </p:nvSpPr>
         <p:spPr>
           <a:xfrm>
-            <a:off x="457200" y="4235500"/>
+            <a:off x="457200" y="4070908"/>
             <a:ext cx="914400" cy="173736"/>
           </a:xfrm>
           <a:prstGeom prst="rect">
@@ -13539,8 +13533,8 @@
         </p:nvSpPr>
         <p:spPr>
           <a:xfrm>
-            <a:off x="1371600" y="4235500"/>
-            <a:ext cx="694944" cy="173736"/>
+            <a:off x="1371600" y="4070908"/>
+            <a:ext cx="603504" cy="173736"/>
           </a:xfrm>
           <a:prstGeom prst="rect">
             <a:avLst/>
@@ -13574,8 +13568,8 @@
         </p:nvSpPr>
         <p:spPr>
           <a:xfrm>
-            <a:off x="2066543" y="4235500"/>
-            <a:ext cx="841248" cy="173736"/>
+            <a:off x="1975104" y="4070908"/>
+            <a:ext cx="914400" cy="173736"/>
           </a:xfrm>
           <a:prstGeom prst="rect">
             <a:avLst/>
@@ -13609,8 +13603,8 @@
         </p:nvSpPr>
         <p:spPr>
           <a:xfrm>
-            <a:off x="2907791" y="4235500"/>
-            <a:ext cx="786384" cy="173736"/>
+            <a:off x="2889504" y="4070908"/>
+            <a:ext cx="914400" cy="173736"/>
           </a:xfrm>
           <a:prstGeom prst="rect">
             <a:avLst/>
@@ -13644,8 +13638,8 @@
         </p:nvSpPr>
         <p:spPr>
           <a:xfrm>
-            <a:off x="3694176" y="4235500"/>
-            <a:ext cx="786384" cy="173736"/>
+            <a:off x="3803904" y="4070908"/>
+            <a:ext cx="731520" cy="173736"/>
           </a:xfrm>
           <a:prstGeom prst="rect">
             <a:avLst/>
@@ -13679,8 +13673,8 @@
         </p:nvSpPr>
         <p:spPr>
           <a:xfrm>
-            <a:off x="4700016" y="4235500"/>
-            <a:ext cx="694944" cy="173736"/>
+            <a:off x="4754880" y="4070908"/>
+            <a:ext cx="603504" cy="173736"/>
           </a:xfrm>
           <a:prstGeom prst="rect">
             <a:avLst/>
@@ -13714,8 +13708,8 @@
         </p:nvSpPr>
         <p:spPr>
           <a:xfrm>
-            <a:off x="5394959" y="4235500"/>
-            <a:ext cx="841248" cy="173736"/>
+            <a:off x="5358384" y="4070908"/>
+            <a:ext cx="914400" cy="173736"/>
           </a:xfrm>
           <a:prstGeom prst="rect">
             <a:avLst/>
@@ -13749,8 +13743,8 @@
         </p:nvSpPr>
         <p:spPr>
           <a:xfrm>
-            <a:off x="6236207" y="4235500"/>
-            <a:ext cx="786384" cy="173736"/>
+            <a:off x="6272784" y="4070908"/>
+            <a:ext cx="914400" cy="173736"/>
           </a:xfrm>
           <a:prstGeom prst="rect">
             <a:avLst/>
@@ -13784,8 +13778,8 @@
         </p:nvSpPr>
         <p:spPr>
           <a:xfrm>
-            <a:off x="7022592" y="4235500"/>
-            <a:ext cx="786384" cy="173736"/>
+            <a:off x="7187184" y="4070908"/>
+            <a:ext cx="731520" cy="173736"/>
           </a:xfrm>
           <a:prstGeom prst="rect">
             <a:avLst/>
@@ -13819,8 +13813,8 @@
         </p:nvSpPr>
         <p:spPr>
           <a:xfrm>
-            <a:off x="8028431" y="4235500"/>
-            <a:ext cx="694944" cy="173736"/>
+            <a:off x="8138160" y="4070908"/>
+            <a:ext cx="603504" cy="173736"/>
           </a:xfrm>
           <a:prstGeom prst="rect">
             <a:avLst/>
@@ -13854,8 +13848,8 @@
         </p:nvSpPr>
         <p:spPr>
           <a:xfrm>
-            <a:off x="8723376" y="4235500"/>
-            <a:ext cx="841248" cy="173736"/>
+            <a:off x="8741664" y="4070908"/>
+            <a:ext cx="914400" cy="173736"/>
           </a:xfrm>
           <a:prstGeom prst="rect">
             <a:avLst/>
@@ -13889,8 +13883,8 @@
         </p:nvSpPr>
         <p:spPr>
           <a:xfrm>
-            <a:off x="9564624" y="4235500"/>
-            <a:ext cx="786384" cy="173736"/>
+            <a:off x="9656064" y="4070908"/>
+            <a:ext cx="914400" cy="173736"/>
           </a:xfrm>
           <a:prstGeom prst="rect">
             <a:avLst/>
@@ -13924,8 +13918,8 @@
         </p:nvSpPr>
         <p:spPr>
           <a:xfrm>
-            <a:off x="10351007" y="4235500"/>
-            <a:ext cx="786384" cy="173736"/>
+            <a:off x="10570464" y="4070908"/>
+            <a:ext cx="731520" cy="173736"/>
           </a:xfrm>
           <a:prstGeom prst="rect">
             <a:avLst/>
@@ -13959,8 +13953,8 @@
         </p:nvCxnSpPr>
         <p:spPr>
           <a:xfrm>
-            <a:off x="457200" y="4465929"/>
-            <a:ext cx="10680191" cy="0"/>
+            <a:off x="457200" y="4301337"/>
+            <a:ext cx="10844784" cy="0"/>
           </a:xfrm>
           <a:prstGeom prst="line">
             <a:avLst/>
@@ -13995,7 +13989,7 @@
         </p:nvSpPr>
         <p:spPr>
           <a:xfrm>
-            <a:off x="457200" y="4520793"/>
+            <a:off x="457200" y="4356201"/>
             <a:ext cx="914400" cy="173736"/>
           </a:xfrm>
           <a:prstGeom prst="rect">
@@ -14030,8 +14024,8 @@
         </p:nvSpPr>
         <p:spPr>
           <a:xfrm>
-            <a:off x="1371600" y="4520793"/>
-            <a:ext cx="694944" cy="173736"/>
+            <a:off x="1371600" y="4356201"/>
+            <a:ext cx="603504" cy="173736"/>
           </a:xfrm>
           <a:prstGeom prst="rect">
             <a:avLst/>
@@ -14065,8 +14059,8 @@
         </p:nvSpPr>
         <p:spPr>
           <a:xfrm>
-            <a:off x="2066543" y="4520793"/>
-            <a:ext cx="841248" cy="173736"/>
+            <a:off x="1975104" y="4356201"/>
+            <a:ext cx="914400" cy="173736"/>
           </a:xfrm>
           <a:prstGeom prst="rect">
             <a:avLst/>
@@ -14100,8 +14094,8 @@
         </p:nvSpPr>
         <p:spPr>
           <a:xfrm>
-            <a:off x="2907791" y="4520793"/>
-            <a:ext cx="786384" cy="173736"/>
+            <a:off x="2889504" y="4356201"/>
+            <a:ext cx="914400" cy="173736"/>
           </a:xfrm>
           <a:prstGeom prst="rect">
             <a:avLst/>
@@ -14135,8 +14129,8 @@
         </p:nvSpPr>
         <p:spPr>
           <a:xfrm>
-            <a:off x="3694176" y="4520793"/>
-            <a:ext cx="786384" cy="173736"/>
+            <a:off x="3803904" y="4356201"/>
+            <a:ext cx="731520" cy="173736"/>
           </a:xfrm>
           <a:prstGeom prst="rect">
             <a:avLst/>
@@ -14170,8 +14164,8 @@
         </p:nvSpPr>
         <p:spPr>
           <a:xfrm>
-            <a:off x="4700016" y="4520793"/>
-            <a:ext cx="694944" cy="173736"/>
+            <a:off x="4754880" y="4356201"/>
+            <a:ext cx="603504" cy="173736"/>
           </a:xfrm>
           <a:prstGeom prst="rect">
             <a:avLst/>
@@ -14205,8 +14199,8 @@
         </p:nvSpPr>
         <p:spPr>
           <a:xfrm>
-            <a:off x="5394959" y="4520793"/>
-            <a:ext cx="841248" cy="173736"/>
+            <a:off x="5358384" y="4356201"/>
+            <a:ext cx="914400" cy="173736"/>
           </a:xfrm>
           <a:prstGeom prst="rect">
             <a:avLst/>
@@ -14240,8 +14234,8 @@
         </p:nvSpPr>
         <p:spPr>
           <a:xfrm>
-            <a:off x="6236207" y="4520793"/>
-            <a:ext cx="786384" cy="173736"/>
+            <a:off x="6272784" y="4356201"/>
+            <a:ext cx="914400" cy="173736"/>
           </a:xfrm>
           <a:prstGeom prst="rect">
             <a:avLst/>
@@ -14275,8 +14269,8 @@
         </p:nvSpPr>
         <p:spPr>
           <a:xfrm>
-            <a:off x="7022592" y="4520793"/>
-            <a:ext cx="786384" cy="173736"/>
+            <a:off x="7187184" y="4356201"/>
+            <a:ext cx="731520" cy="173736"/>
           </a:xfrm>
           <a:prstGeom prst="rect">
             <a:avLst/>
@@ -14310,8 +14304,8 @@
         </p:nvSpPr>
         <p:spPr>
           <a:xfrm>
-            <a:off x="8028431" y="4520793"/>
-            <a:ext cx="694944" cy="173736"/>
+            <a:off x="8138160" y="4356201"/>
+            <a:ext cx="603504" cy="173736"/>
           </a:xfrm>
           <a:prstGeom prst="rect">
             <a:avLst/>
@@ -14345,8 +14339,8 @@
         </p:nvSpPr>
         <p:spPr>
           <a:xfrm>
-            <a:off x="8723376" y="4520793"/>
-            <a:ext cx="841248" cy="173736"/>
+            <a:off x="8741664" y="4356201"/>
+            <a:ext cx="914400" cy="173736"/>
           </a:xfrm>
           <a:prstGeom prst="rect">
             <a:avLst/>
@@ -14380,8 +14374,8 @@
         </p:nvSpPr>
         <p:spPr>
           <a:xfrm>
-            <a:off x="9564624" y="4520793"/>
-            <a:ext cx="786384" cy="173736"/>
+            <a:off x="9656064" y="4356201"/>
+            <a:ext cx="914400" cy="173736"/>
           </a:xfrm>
           <a:prstGeom prst="rect">
             <a:avLst/>
@@ -14415,8 +14409,8 @@
         </p:nvSpPr>
         <p:spPr>
           <a:xfrm>
-            <a:off x="10351007" y="4520793"/>
-            <a:ext cx="786384" cy="173736"/>
+            <a:off x="10570464" y="4356201"/>
+            <a:ext cx="731520" cy="173736"/>
           </a:xfrm>
           <a:prstGeom prst="rect">
             <a:avLst/>
@@ -14450,7 +14444,7 @@
         </p:nvSpPr>
         <p:spPr>
           <a:xfrm>
-            <a:off x="457200" y="4749393"/>
+            <a:off x="457200" y="4584801"/>
             <a:ext cx="3291840" cy="173736"/>
           </a:xfrm>
           <a:prstGeom prst="rect">
@@ -14472,7 +14466,7 @@
                 </a:solidFill>
                 <a:latin typeface="Garamond"/>
               </a:rPr>
-              <a:t>Distinct persons (New + Last year)</a:t>
+              <a:t>Distinct persons (New + Seen last yr)</a:t>
             </a:r>
           </a:p>
         </p:txBody>
@@ -14485,8 +14479,8 @@
         </p:nvSpPr>
         <p:spPr>
           <a:xfrm>
-            <a:off x="1371600" y="4749393"/>
-            <a:ext cx="3108960" cy="173736"/>
+            <a:off x="1371600" y="4584801"/>
+            <a:ext cx="3163824" cy="173736"/>
           </a:xfrm>
           <a:prstGeom prst="rect">
             <a:avLst/>
@@ -14520,8 +14514,8 @@
         </p:nvSpPr>
         <p:spPr>
           <a:xfrm>
-            <a:off x="4700016" y="4749393"/>
-            <a:ext cx="3108960" cy="173736"/>
+            <a:off x="4754880" y="4584801"/>
+            <a:ext cx="3163824" cy="173736"/>
           </a:xfrm>
           <a:prstGeom prst="rect">
             <a:avLst/>
@@ -14555,8 +14549,8 @@
         </p:nvSpPr>
         <p:spPr>
           <a:xfrm>
-            <a:off x="8028431" y="4749393"/>
-            <a:ext cx="3108960" cy="173736"/>
+            <a:off x="8138160" y="4584801"/>
+            <a:ext cx="3163824" cy="173736"/>
           </a:xfrm>
           <a:prstGeom prst="rect">
             <a:avLst/>
@@ -14590,7 +14584,7 @@
         </p:nvSpPr>
         <p:spPr>
           <a:xfrm>
-            <a:off x="457200" y="4977993"/>
+            <a:off x="457200" y="4813401"/>
             <a:ext cx="3291840" cy="173736"/>
           </a:xfrm>
           <a:prstGeom prst="rect">
@@ -14625,8 +14619,8 @@
         </p:nvSpPr>
         <p:spPr>
           <a:xfrm>
-            <a:off x="1371600" y="4977993"/>
-            <a:ext cx="3108960" cy="173736"/>
+            <a:off x="1371600" y="4813401"/>
+            <a:ext cx="3163824" cy="173736"/>
           </a:xfrm>
           <a:prstGeom prst="rect">
             <a:avLst/>
@@ -14660,8 +14654,8 @@
         </p:nvSpPr>
         <p:spPr>
           <a:xfrm>
-            <a:off x="4700016" y="4977993"/>
-            <a:ext cx="3108960" cy="173736"/>
+            <a:off x="4754880" y="4813401"/>
+            <a:ext cx="3163824" cy="173736"/>
           </a:xfrm>
           <a:prstGeom prst="rect">
             <a:avLst/>
@@ -14695,8 +14689,8 @@
         </p:nvSpPr>
         <p:spPr>
           <a:xfrm>
-            <a:off x="8028431" y="4977993"/>
-            <a:ext cx="3108960" cy="173736"/>
+            <a:off x="8138160" y="4813401"/>
+            <a:ext cx="3163824" cy="173736"/>
           </a:xfrm>
           <a:prstGeom prst="rect">
             <a:avLst/>
@@ -14730,8 +14724,8 @@
         </p:nvCxnSpPr>
         <p:spPr>
           <a:xfrm>
-            <a:off x="457200" y="5206593"/>
-            <a:ext cx="10680191" cy="0"/>
+            <a:off x="457200" y="5042001"/>
+            <a:ext cx="10844784" cy="0"/>
           </a:xfrm>
           <a:prstGeom prst="line">
             <a:avLst/>
@@ -14766,7 +14760,7 @@
         </p:nvSpPr>
         <p:spPr>
           <a:xfrm>
-            <a:off x="457200" y="5325465"/>
+            <a:off x="457200" y="5160873"/>
             <a:ext cx="11247120" cy="173736"/>
           </a:xfrm>
           <a:prstGeom prst="rect">
@@ -14788,7 +14782,7 @@
                 </a:solidFill>
                 <a:latin typeface="Garamond"/>
               </a:rPr>
-              <a:t>Adults (18+); every cell counts persons. Within a month: New + Earlier this year + Last year = Total, the month’s interviews (≈100k in the 2000s). Down a column: the Totals sum to the year’s interviews (2006: 1,221,832), while New + Last year counts each person exactly once → distinct persons (2006: 203,820 + 178,187 = 382,007). The ASEC = the March respondents + the February–April oversamples: 38% of the distinct persons, 12% of the interviews, 1.45× a single March.</a:t>
+              <a:t>Adults (18+); every cell counts persons. Within a month: New + Seen this yr + Seen last yr = Total, the month’s interviews (≈100k in the 2000s). Down a column: the Totals sum to the year’s interviews (2006: 1,221,832), while New + Seen last yr counts each person exactly once → distinct persons (2006: 203,820 + 178,187 = 382,007). The ASEC = the March respondents + the February–April oversamples: 38% of the distinct persons, 12% of the interviews, 1.45× a single March.</a:t>
             </a:r>
           </a:p>
         </p:txBody>

</xml_diff>

<commit_message>
Booktabs rule weights on the sample tables
Co-Authored-By: Claude Fable 5 <noreply@anthropic.com>
Claude-Session: https://claude.ai/code/session_01DNzQPDcr3zfLTraMHUHqUn
</commit_message>
<xml_diff>
--- a/report/data_cluster/sample_sizes_slides.pptx
+++ b/report/data_cluster/sample_sizes_slides.pptx
@@ -3131,13 +3131,13 @@
         </p:nvCxnSpPr>
         <p:spPr>
           <a:xfrm>
-            <a:off x="685800" y="1252728"/>
+            <a:off x="685800" y="1234439"/>
             <a:ext cx="4206240" cy="0"/>
           </a:xfrm>
           <a:prstGeom prst="line">
             <a:avLst/>
           </a:prstGeom>
-          <a:ln w="12700">
+          <a:ln w="17780">
             <a:solidFill>
               <a:srgbClr val="212529"/>
             </a:solidFill>
@@ -3307,13 +3307,13 @@
         </p:nvCxnSpPr>
         <p:spPr>
           <a:xfrm>
-            <a:off x="685800" y="1536192"/>
+            <a:off x="685800" y="1545336"/>
             <a:ext cx="4206240" cy="0"/>
           </a:xfrm>
           <a:prstGeom prst="line">
             <a:avLst/>
           </a:prstGeom>
-          <a:ln w="12700">
+          <a:ln w="7620">
             <a:solidFill>
               <a:srgbClr val="212529"/>
             </a:solidFill>
@@ -5303,13 +5303,13 @@
         </p:nvCxnSpPr>
         <p:spPr>
           <a:xfrm>
-            <a:off x="685800" y="5100523"/>
+            <a:off x="685800" y="5109667"/>
             <a:ext cx="4206240" cy="0"/>
           </a:xfrm>
           <a:prstGeom prst="line">
             <a:avLst/>
           </a:prstGeom>
-          <a:ln w="12700">
+          <a:ln w="17780">
             <a:solidFill>
               <a:srgbClr val="212529"/>
             </a:solidFill>
@@ -5339,13 +5339,13 @@
         </p:nvCxnSpPr>
         <p:spPr>
           <a:xfrm>
-            <a:off x="6583680" y="1252728"/>
+            <a:off x="6583680" y="1234439"/>
             <a:ext cx="4206240" cy="0"/>
           </a:xfrm>
           <a:prstGeom prst="line">
             <a:avLst/>
           </a:prstGeom>
-          <a:ln w="12700">
+          <a:ln w="17780">
             <a:solidFill>
               <a:srgbClr val="212529"/>
             </a:solidFill>
@@ -5515,13 +5515,13 @@
         </p:nvCxnSpPr>
         <p:spPr>
           <a:xfrm>
-            <a:off x="6583680" y="1536192"/>
+            <a:off x="6583680" y="1545336"/>
             <a:ext cx="4206240" cy="0"/>
           </a:xfrm>
           <a:prstGeom prst="line">
             <a:avLst/>
           </a:prstGeom>
-          <a:ln w="12700">
+          <a:ln w="7620">
             <a:solidFill>
               <a:srgbClr val="212529"/>
             </a:solidFill>
@@ -7511,13 +7511,13 @@
         </p:nvCxnSpPr>
         <p:spPr>
           <a:xfrm>
-            <a:off x="6583680" y="5100523"/>
+            <a:off x="6583680" y="5109667"/>
             <a:ext cx="4206240" cy="0"/>
           </a:xfrm>
           <a:prstGeom prst="line">
             <a:avLst/>
           </a:prstGeom>
-          <a:ln w="12700">
+          <a:ln w="17780">
             <a:solidFill>
               <a:srgbClr val="212529"/>
             </a:solidFill>
@@ -7896,13 +7896,13 @@
         </p:nvCxnSpPr>
         <p:spPr>
           <a:xfrm>
-            <a:off x="457200" y="1106424"/>
+            <a:off x="457200" y="1088136"/>
             <a:ext cx="10844784" cy="0"/>
           </a:xfrm>
           <a:prstGeom prst="line">
             <a:avLst/>
           </a:prstGeom>
-          <a:ln w="12700">
+          <a:ln w="17780">
             <a:solidFill>
               <a:srgbClr val="212529"/>
             </a:solidFill>
@@ -8463,7 +8463,7 @@
           <a:prstGeom prst="line">
             <a:avLst/>
           </a:prstGeom>
-          <a:ln w="12700">
+          <a:ln w="7620">
             <a:solidFill>
               <a:srgbClr val="212529"/>
             </a:solidFill>
@@ -13959,7 +13959,7 @@
           <a:prstGeom prst="line">
             <a:avLst/>
           </a:prstGeom>
-          <a:ln w="12700">
+          <a:ln w="7620">
             <a:solidFill>
               <a:srgbClr val="212529"/>
             </a:solidFill>
@@ -14730,7 +14730,7 @@
           <a:prstGeom prst="line">
             <a:avLst/>
           </a:prstGeom>
-          <a:ln w="12700">
+          <a:ln w="17780">
             <a:solidFill>
               <a:srgbClr val="212529"/>
             </a:solidFill>

</xml_diff>